<commit_message>
Update PowerPoint for song #229 in FUBC - Українські
</commit_message>
<xml_diff>
--- a/fubc-ua/229-Юний цвіт життя (Пісні Спасенних №228).pptx
+++ b/fubc-ua/229-Юний цвіт життя (Пісні Спасенних №228).pptx
@@ -1627,7 +1627,7 @@
         </p:nvSpPr>
         <p:spPr>
           <a:xfrm>
-            <a:off x="2198065" y="3151632"/>
+            <a:off x="2297125" y="3151632"/>
             <a:ext cx="0" cy="2179320"/>
           </a:xfrm>
           <a:prstGeom prst="line">
@@ -1650,7 +1650,7 @@
         </p:nvSpPr>
         <p:spPr>
           <a:xfrm>
-            <a:off x="10000031" y="3151632"/>
+            <a:off x="9900971" y="3151632"/>
             <a:ext cx="0" cy="2179320"/>
           </a:xfrm>
           <a:prstGeom prst="line">
@@ -1673,8 +1673,8 @@
         </p:nvSpPr>
         <p:spPr>
           <a:xfrm>
-            <a:off x="10132111" y="4010152"/>
-            <a:ext cx="792480" cy="462280"/>
+            <a:off x="10000031" y="3921252"/>
+            <a:ext cx="1097280" cy="640080"/>
           </a:xfrm>
           <a:prstGeom prst="rect">
             <a:avLst/>
@@ -1690,9 +1690,9 @@
               <a:buNone/>
             </a:pPr>
             <a:r>
-              <a:rPr lang="en-US" sz="2600" b="1" dirty="0">
-                <a:solidFill>
-                  <a:srgbClr val="8A8A8A"/>
+              <a:rPr lang="en-US" sz="3600" b="1" dirty="0">
+                <a:solidFill>
+                  <a:srgbClr val="BBBBBB"/>
                 </a:solidFill>
                 <a:latin typeface="Arial" pitchFamily="34" charset="0"/>
                 <a:ea typeface="Arial" pitchFamily="34" charset="-122"/>
@@ -1700,7 +1700,7 @@
               </a:rPr>
               <a:t>×2</a:t>
             </a:r>
-            <a:endParaRPr lang="en-US" sz="2600" dirty="0"/>
+            <a:endParaRPr lang="en-US" sz="3600" dirty="0"/>
           </a:p>
         </p:txBody>
       </p:sp>
@@ -1866,7 +1866,7 @@
         </p:nvSpPr>
         <p:spPr>
           <a:xfrm>
-            <a:off x="2345334" y="3151632"/>
+            <a:off x="2444394" y="3151632"/>
             <a:ext cx="0" cy="2179320"/>
           </a:xfrm>
           <a:prstGeom prst="line">
@@ -1889,7 +1889,7 @@
         </p:nvSpPr>
         <p:spPr>
           <a:xfrm>
-            <a:off x="9852762" y="3151632"/>
+            <a:off x="9753702" y="3151632"/>
             <a:ext cx="0" cy="2179320"/>
           </a:xfrm>
           <a:prstGeom prst="line">
@@ -1912,8 +1912,8 @@
         </p:nvSpPr>
         <p:spPr>
           <a:xfrm>
-            <a:off x="9984842" y="4010152"/>
-            <a:ext cx="792480" cy="462280"/>
+            <a:off x="9852762" y="3921252"/>
+            <a:ext cx="1097280" cy="640080"/>
           </a:xfrm>
           <a:prstGeom prst="rect">
             <a:avLst/>
@@ -1929,9 +1929,9 @@
               <a:buNone/>
             </a:pPr>
             <a:r>
-              <a:rPr lang="en-US" sz="2600" b="1" dirty="0">
-                <a:solidFill>
-                  <a:srgbClr val="8A8A8A"/>
+              <a:rPr lang="en-US" sz="3600" b="1" dirty="0">
+                <a:solidFill>
+                  <a:srgbClr val="BBBBBB"/>
                 </a:solidFill>
                 <a:latin typeface="Arial" pitchFamily="34" charset="0"/>
                 <a:ea typeface="Arial" pitchFamily="34" charset="-122"/>
@@ -1939,7 +1939,7 @@
               </a:rPr>
               <a:t>×2</a:t>
             </a:r>
-            <a:endParaRPr lang="en-US" sz="2600" dirty="0"/>
+            <a:endParaRPr lang="en-US" sz="3600" dirty="0"/>
           </a:p>
         </p:txBody>
       </p:sp>
@@ -2105,7 +2105,7 @@
         </p:nvSpPr>
         <p:spPr>
           <a:xfrm>
-            <a:off x="2166696" y="3151632"/>
+            <a:off x="2265756" y="3151632"/>
             <a:ext cx="0" cy="2179320"/>
           </a:xfrm>
           <a:prstGeom prst="line">
@@ -2128,7 +2128,7 @@
         </p:nvSpPr>
         <p:spPr>
           <a:xfrm>
-            <a:off x="10031400" y="3151632"/>
+            <a:off x="9932340" y="3151632"/>
             <a:ext cx="0" cy="2179320"/>
           </a:xfrm>
           <a:prstGeom prst="line">
@@ -2151,8 +2151,8 @@
         </p:nvSpPr>
         <p:spPr>
           <a:xfrm>
-            <a:off x="10163480" y="4010152"/>
-            <a:ext cx="792480" cy="462280"/>
+            <a:off x="10031400" y="3921252"/>
+            <a:ext cx="1097280" cy="640080"/>
           </a:xfrm>
           <a:prstGeom prst="rect">
             <a:avLst/>
@@ -2168,9 +2168,9 @@
               <a:buNone/>
             </a:pPr>
             <a:r>
-              <a:rPr lang="en-US" sz="2600" b="1" dirty="0">
-                <a:solidFill>
-                  <a:srgbClr val="8A8A8A"/>
+              <a:rPr lang="en-US" sz="3600" b="1" dirty="0">
+                <a:solidFill>
+                  <a:srgbClr val="BBBBBB"/>
                 </a:solidFill>
                 <a:latin typeface="Arial" pitchFamily="34" charset="0"/>
                 <a:ea typeface="Arial" pitchFamily="34" charset="-122"/>
@@ -2178,7 +2178,7 @@
               </a:rPr>
               <a:t>×2</a:t>
             </a:r>
-            <a:endParaRPr lang="en-US" sz="2600" dirty="0"/>
+            <a:endParaRPr lang="en-US" sz="3600" dirty="0"/>
           </a:p>
         </p:txBody>
       </p:sp>
@@ -2364,7 +2364,7 @@
         </p:nvSpPr>
         <p:spPr>
           <a:xfrm>
-            <a:off x="1179398" y="3547872"/>
+            <a:off x="1278458" y="3547872"/>
             <a:ext cx="0" cy="2179320"/>
           </a:xfrm>
           <a:prstGeom prst="line">
@@ -2387,7 +2387,7 @@
         </p:nvSpPr>
         <p:spPr>
           <a:xfrm>
-            <a:off x="11018698" y="3547872"/>
+            <a:off x="10919638" y="3547872"/>
             <a:ext cx="0" cy="2179320"/>
           </a:xfrm>
           <a:prstGeom prst="line">
@@ -2410,8 +2410,8 @@
         </p:nvSpPr>
         <p:spPr>
           <a:xfrm>
-            <a:off x="11150778" y="4406392"/>
-            <a:ext cx="792480" cy="462280"/>
+            <a:off x="11018698" y="4317492"/>
+            <a:ext cx="1097280" cy="640080"/>
           </a:xfrm>
           <a:prstGeom prst="rect">
             <a:avLst/>
@@ -2427,9 +2427,9 @@
               <a:buNone/>
             </a:pPr>
             <a:r>
-              <a:rPr lang="en-US" sz="2600" b="1" dirty="0">
-                <a:solidFill>
-                  <a:srgbClr val="8A8A8A"/>
+              <a:rPr lang="en-US" sz="3600" b="1" dirty="0">
+                <a:solidFill>
+                  <a:srgbClr val="BBBBBB"/>
                 </a:solidFill>
                 <a:latin typeface="Arial" pitchFamily="34" charset="0"/>
                 <a:ea typeface="Arial" pitchFamily="34" charset="-122"/>
@@ -2437,7 +2437,7 @@
               </a:rPr>
               <a:t>×2</a:t>
             </a:r>
-            <a:endParaRPr lang="en-US" sz="2600" dirty="0"/>
+            <a:endParaRPr lang="en-US" sz="3600" dirty="0"/>
           </a:p>
         </p:txBody>
       </p:sp>
@@ -2643,7 +2643,7 @@
         </p:nvSpPr>
         <p:spPr>
           <a:xfrm>
-            <a:off x="2494255" y="3151632"/>
+            <a:off x="2593315" y="3151632"/>
             <a:ext cx="0" cy="2971800"/>
           </a:xfrm>
           <a:prstGeom prst="line">
@@ -2666,7 +2666,7 @@
         </p:nvSpPr>
         <p:spPr>
           <a:xfrm>
-            <a:off x="9703841" y="3151632"/>
+            <a:off x="9604781" y="3151632"/>
             <a:ext cx="0" cy="2971800"/>
           </a:xfrm>
           <a:prstGeom prst="line">
@@ -2689,8 +2689,8 @@
         </p:nvSpPr>
         <p:spPr>
           <a:xfrm>
-            <a:off x="9835921" y="4406392"/>
-            <a:ext cx="792480" cy="462280"/>
+            <a:off x="9703841" y="4317492"/>
+            <a:ext cx="1097280" cy="640080"/>
           </a:xfrm>
           <a:prstGeom prst="rect">
             <a:avLst/>
@@ -2706,9 +2706,9 @@
               <a:buNone/>
             </a:pPr>
             <a:r>
-              <a:rPr lang="en-US" sz="2600" b="1" dirty="0">
-                <a:solidFill>
-                  <a:srgbClr val="8A8A8A"/>
+              <a:rPr lang="en-US" sz="3600" b="1" dirty="0">
+                <a:solidFill>
+                  <a:srgbClr val="BBBBBB"/>
                 </a:solidFill>
                 <a:latin typeface="Arial" pitchFamily="34" charset="0"/>
                 <a:ea typeface="Arial" pitchFamily="34" charset="-122"/>
@@ -2716,7 +2716,7 @@
               </a:rPr>
               <a:t>×2</a:t>
             </a:r>
-            <a:endParaRPr lang="en-US" sz="2600" dirty="0"/>
+            <a:endParaRPr lang="en-US" sz="3600" dirty="0"/>
           </a:p>
         </p:txBody>
       </p:sp>

</xml_diff>